<commit_message>
Text-line section caps, DMDS overflow-box split, webtool picker UI, feed robustness
</commit_message>
<xml_diff>
--- a/SCDS Slide template.pptx
+++ b/SCDS Slide template.pptx
@@ -281,7 +281,7 @@
           <a:p>
             <a:fld id="{994A2B85-D722-4673-8314-E6AD4D0580D4}" type="datetimeFigureOut">
               <a:rPr lang="en-CA" smtClean="0"/>
-              <a:t>2026-08-21</a:t>
+              <a:t>2026-08-24</a:t>
             </a:fld>
             <a:endParaRPr lang="en-CA"/>
           </a:p>
@@ -866,7 +866,7 @@
           <a:p>
             <a:fld id="{76B3B3C8-25F1-4201-B40C-5812AD79D5C6}" type="datetimeFigureOut">
               <a:rPr lang="en-CA" smtClean="0"/>
-              <a:t>2026-08-21</a:t>
+              <a:t>2026-08-24</a:t>
             </a:fld>
             <a:endParaRPr lang="en-CA"/>
           </a:p>
@@ -1066,7 +1066,7 @@
           <a:p>
             <a:fld id="{76B3B3C8-25F1-4201-B40C-5812AD79D5C6}" type="datetimeFigureOut">
               <a:rPr lang="en-CA" smtClean="0"/>
-              <a:t>2026-08-21</a:t>
+              <a:t>2026-08-24</a:t>
             </a:fld>
             <a:endParaRPr lang="en-CA"/>
           </a:p>
@@ -1276,7 +1276,7 @@
           <a:p>
             <a:fld id="{76B3B3C8-25F1-4201-B40C-5812AD79D5C6}" type="datetimeFigureOut">
               <a:rPr lang="en-CA" smtClean="0"/>
-              <a:t>2026-08-21</a:t>
+              <a:t>2026-08-24</a:t>
             </a:fld>
             <a:endParaRPr lang="en-CA"/>
           </a:p>
@@ -1476,7 +1476,7 @@
           <a:p>
             <a:fld id="{76B3B3C8-25F1-4201-B40C-5812AD79D5C6}" type="datetimeFigureOut">
               <a:rPr lang="en-CA" smtClean="0"/>
-              <a:t>2026-08-21</a:t>
+              <a:t>2026-08-24</a:t>
             </a:fld>
             <a:endParaRPr lang="en-CA"/>
           </a:p>
@@ -1752,7 +1752,7 @@
           <a:p>
             <a:fld id="{76B3B3C8-25F1-4201-B40C-5812AD79D5C6}" type="datetimeFigureOut">
               <a:rPr lang="en-CA" smtClean="0"/>
-              <a:t>2026-08-21</a:t>
+              <a:t>2026-08-24</a:t>
             </a:fld>
             <a:endParaRPr lang="en-CA"/>
           </a:p>
@@ -2020,7 +2020,7 @@
           <a:p>
             <a:fld id="{76B3B3C8-25F1-4201-B40C-5812AD79D5C6}" type="datetimeFigureOut">
               <a:rPr lang="en-CA" smtClean="0"/>
-              <a:t>2026-08-21</a:t>
+              <a:t>2026-08-24</a:t>
             </a:fld>
             <a:endParaRPr lang="en-CA"/>
           </a:p>
@@ -2435,7 +2435,7 @@
           <a:p>
             <a:fld id="{76B3B3C8-25F1-4201-B40C-5812AD79D5C6}" type="datetimeFigureOut">
               <a:rPr lang="en-CA" smtClean="0"/>
-              <a:t>2026-08-21</a:t>
+              <a:t>2026-08-24</a:t>
             </a:fld>
             <a:endParaRPr lang="en-CA"/>
           </a:p>
@@ -2577,7 +2577,7 @@
           <a:p>
             <a:fld id="{76B3B3C8-25F1-4201-B40C-5812AD79D5C6}" type="datetimeFigureOut">
               <a:rPr lang="en-CA" smtClean="0"/>
-              <a:t>2026-08-21</a:t>
+              <a:t>2026-08-24</a:t>
             </a:fld>
             <a:endParaRPr lang="en-CA"/>
           </a:p>
@@ -2690,7 +2690,7 @@
           <a:p>
             <a:fld id="{76B3B3C8-25F1-4201-B40C-5812AD79D5C6}" type="datetimeFigureOut">
               <a:rPr lang="en-CA" smtClean="0"/>
-              <a:t>2026-08-21</a:t>
+              <a:t>2026-08-24</a:t>
             </a:fld>
             <a:endParaRPr lang="en-CA"/>
           </a:p>
@@ -3003,7 +3003,7 @@
           <a:p>
             <a:fld id="{76B3B3C8-25F1-4201-B40C-5812AD79D5C6}" type="datetimeFigureOut">
               <a:rPr lang="en-CA" smtClean="0"/>
-              <a:t>2026-08-21</a:t>
+              <a:t>2026-08-24</a:t>
             </a:fld>
             <a:endParaRPr lang="en-CA"/>
           </a:p>
@@ -3292,7 +3292,7 @@
           <a:p>
             <a:fld id="{76B3B3C8-25F1-4201-B40C-5812AD79D5C6}" type="datetimeFigureOut">
               <a:rPr lang="en-CA" smtClean="0"/>
-              <a:t>2026-08-21</a:t>
+              <a:t>2026-08-24</a:t>
             </a:fld>
             <a:endParaRPr lang="en-CA"/>
           </a:p>
@@ -3535,7 +3535,7 @@
           <a:p>
             <a:fld id="{76B3B3C8-25F1-4201-B40C-5812AD79D5C6}" type="datetimeFigureOut">
               <a:rPr lang="en-CA" smtClean="0"/>
-              <a:t>2026-08-21</a:t>
+              <a:t>2026-08-24</a:t>
             </a:fld>
             <a:endParaRPr lang="en-CA"/>
           </a:p>
@@ -3968,14 +3968,14 @@
             </a:extLst>
           </p:cNvPr>
           <p:cNvSpPr>
-            <a:spLocks noGrp="1" noRot="1" noMove="1" noResize="1" noEditPoints="1" noAdjustHandles="1" noChangeArrowheads="1" noChangeShapeType="1"/>
+            <a:spLocks/>
           </p:cNvSpPr>
           <p:nvPr/>
         </p:nvSpPr>
         <p:spPr>
           <a:xfrm>
-            <a:off x="685801" y="1014205"/>
-            <a:ext cx="10820398" cy="4886384"/>
+            <a:off x="647999" y="3168000"/>
+            <a:ext cx="5400000" cy="2700000"/>
           </a:xfrm>
           <a:prstGeom prst="rect">
             <a:avLst/>
@@ -4102,7 +4102,7 @@
               <a:defRPr/>
             </a:pPr>
             <a:r>
-              <a:rPr kumimoji="0" lang="en-CA" sz="2400" b="1" i="0" u="none" strike="noStrike" kern="1200" cap="none" spc="0" normalizeH="0" baseline="0" noProof="0">
+              <a:rPr kumimoji="0" lang="en-CA" sz="2400" b="1" i="0" u="none" strike="noStrike" kern="1200" cap="none" spc="0" normalizeH="0" baseline="0" noProof="0" dirty="0">
                 <a:ln>
                   <a:noFill/>
                 </a:ln>
@@ -4131,14 +4131,14 @@
             </a:extLst>
           </p:cNvPr>
           <p:cNvSpPr>
-            <a:spLocks noGrp="1" noRot="1" noMove="1" noResize="1" noEditPoints="1" noAdjustHandles="1" noChangeArrowheads="1" noChangeShapeType="1"/>
+            <a:spLocks/>
           </p:cNvSpPr>
           <p:nvPr/>
         </p:nvSpPr>
         <p:spPr>
           <a:xfrm>
-            <a:off x="685799" y="1012307"/>
-            <a:ext cx="5410199" cy="2180992"/>
+            <a:off x="648000" y="1008000"/>
+            <a:ext cx="5400000" cy="2160000"/>
           </a:xfrm>
           <a:prstGeom prst="rect">
             <a:avLst/>
@@ -5509,14 +5509,14 @@
             </a:extLst>
           </p:cNvPr>
           <p:cNvSpPr>
-            <a:spLocks noGrp="1" noRot="1" noMove="1" noResize="1" noEditPoints="1" noAdjustHandles="1" noChangeArrowheads="1" noChangeShapeType="1"/>
+            <a:spLocks/>
           </p:cNvSpPr>
           <p:nvPr/>
         </p:nvSpPr>
         <p:spPr>
           <a:xfrm>
-            <a:off x="6095996" y="1014206"/>
-            <a:ext cx="5410199" cy="2179094"/>
+            <a:off x="6048000" y="1008000"/>
+            <a:ext cx="5400000" cy="2160000"/>
           </a:xfrm>
           <a:prstGeom prst="rect">
             <a:avLst/>
@@ -5592,14 +5592,14 @@
             </a:extLst>
           </p:cNvPr>
           <p:cNvSpPr>
-            <a:spLocks noGrp="1" noRot="1" noMove="1" noResize="1" noEditPoints="1" noAdjustHandles="1" noChangeArrowheads="1" noChangeShapeType="1"/>
+            <a:spLocks/>
           </p:cNvSpPr>
           <p:nvPr/>
         </p:nvSpPr>
         <p:spPr>
           <a:xfrm>
-            <a:off x="6095992" y="3193299"/>
-            <a:ext cx="5410199" cy="2709189"/>
+            <a:off x="6048000" y="3168000"/>
+            <a:ext cx="5400000" cy="2700000"/>
           </a:xfrm>
           <a:prstGeom prst="rect">
             <a:avLst/>
@@ -5679,8 +5679,8 @@
         </p:nvSpPr>
         <p:spPr>
           <a:xfrm>
-            <a:off x="852996" y="1178046"/>
-            <a:ext cx="5179849" cy="1621429"/>
+            <a:off x="756000" y="1116000"/>
+            <a:ext cx="5184000" cy="1944000"/>
           </a:xfrm>
           <a:prstGeom prst="rect">
             <a:avLst/>
@@ -5962,72 +5962,6 @@
               <a:t>Create an Interactive Dashboard using ArcGIS</a:t>
             </a:r>
           </a:p>
-          <a:p>
-            <a:pPr marL="0" marR="0" lvl="0" indent="0" algn="l" defTabSz="1523848" rtl="0" eaLnBrk="1" fontAlgn="auto" latinLnBrk="0" hangingPunct="1">
-              <a:lnSpc>
-                <a:spcPct val="100000"/>
-              </a:lnSpc>
-              <a:spcBef>
-                <a:spcPts val="0"/>
-              </a:spcBef>
-              <a:spcAft>
-                <a:spcPts val="0"/>
-              </a:spcAft>
-              <a:buClrTx/>
-              <a:buSzTx/>
-              <a:buFont typeface="Arial" panose="020B0604020202020204" pitchFamily="34" charset="0"/>
-              <a:buNone/>
-              <a:tabLst/>
-              <a:defRPr/>
-            </a:pPr>
-            <a:endParaRPr kumimoji="0" lang="en-US" sz="1600" i="0" u="none" strike="noStrike" kern="1200" cap="none" spc="0" normalizeH="0" baseline="0" noProof="0" dirty="0">
-              <a:ln>
-                <a:noFill/>
-              </a:ln>
-              <a:solidFill>
-                <a:srgbClr val="FFFFFF"/>
-              </a:solidFill>
-              <a:effectLst/>
-              <a:uLnTx/>
-              <a:uFillTx/>
-              <a:latin typeface="Aptos" panose="020B0004020202020204" pitchFamily="34" charset="0"/>
-              <a:ea typeface="+mn-ea"/>
-              <a:cs typeface="+mn-cs"/>
-            </a:endParaRPr>
-          </a:p>
-          <a:p>
-            <a:pPr marL="0" marR="0" lvl="0" indent="0" algn="l" defTabSz="1523848" rtl="0" eaLnBrk="1" fontAlgn="auto" latinLnBrk="0" hangingPunct="1">
-              <a:lnSpc>
-                <a:spcPct val="100000"/>
-              </a:lnSpc>
-              <a:spcBef>
-                <a:spcPts val="0"/>
-              </a:spcBef>
-              <a:spcAft>
-                <a:spcPts val="0"/>
-              </a:spcAft>
-              <a:buClrTx/>
-              <a:buSzTx/>
-              <a:buFont typeface="Arial" panose="020B0604020202020204" pitchFamily="34" charset="0"/>
-              <a:buNone/>
-              <a:tabLst/>
-              <a:defRPr/>
-            </a:pPr>
-            <a:endParaRPr kumimoji="0" lang="en-US" sz="1600" i="0" u="none" strike="noStrike" kern="1200" cap="none" spc="0" normalizeH="0" baseline="0" noProof="0" dirty="0">
-              <a:ln>
-                <a:noFill/>
-              </a:ln>
-              <a:solidFill>
-                <a:srgbClr val="FFFFFF"/>
-              </a:solidFill>
-              <a:effectLst/>
-              <a:uLnTx/>
-              <a:uFillTx/>
-              <a:latin typeface="Aptos" panose="020B0004020202020204" pitchFamily="34" charset="0"/>
-              <a:ea typeface="+mn-ea"/>
-              <a:cs typeface="+mn-cs"/>
-            </a:endParaRPr>
-          </a:p>
         </p:txBody>
       </p:sp>
       <p:sp>
@@ -6046,8 +5980,8 @@
         </p:nvSpPr>
         <p:spPr>
           <a:xfrm>
-            <a:off x="6322527" y="3363179"/>
-            <a:ext cx="4914293" cy="2291142"/>
+            <a:off x="6155999" y="3276000"/>
+            <a:ext cx="5184000" cy="864000"/>
           </a:xfrm>
           <a:prstGeom prst="rect">
             <a:avLst/>
@@ -6238,7 +6172,7 @@
               <a:defRPr/>
             </a:pPr>
             <a:r>
-              <a:rPr kumimoji="0" lang="en-GB" sz="2000" b="1" i="0" u="none" strike="noStrike" kern="1200" cap="none" spc="0" normalizeH="0" baseline="0" noProof="0">
+              <a:rPr kumimoji="0" lang="en-GB" sz="2000" b="1" i="0" u="none" strike="noStrike" kern="1200" cap="none" spc="0" normalizeH="0" baseline="0" noProof="0" dirty="0">
                 <a:ln>
                   <a:noFill/>
                 </a:ln>
@@ -6274,7 +6208,7 @@
               <a:defRPr/>
             </a:pPr>
             <a:r>
-              <a:rPr lang="en-GB" sz="1600" b="1">
+              <a:rPr lang="en-GB" sz="1600" b="1" dirty="0">
                 <a:solidFill>
                   <a:srgbClr val="FFFFFF"/>
                 </a:solidFill>
@@ -6283,7 +6217,7 @@
               <a:t>February 25: </a:t>
             </a:r>
             <a:r>
-              <a:rPr lang="en-US" sz="1600">
+              <a:rPr lang="en-US" sz="1600" dirty="0">
                 <a:solidFill>
                   <a:srgbClr val="FFFFFF"/>
                 </a:solidFill>
@@ -6291,7 +6225,7 @@
               </a:rPr>
               <a:t>Build Your Own Chatbot: Local Applications in Generative AI on your Laptop</a:t>
             </a:r>
-            <a:endParaRPr kumimoji="0" lang="en-GB" sz="1600" i="0" u="none" strike="noStrike" kern="1200" cap="none" spc="0" normalizeH="0" baseline="0" noProof="0">
+            <a:endParaRPr kumimoji="0" lang="en-GB" sz="1600" i="0" u="none" strike="noStrike" kern="1200" cap="none" spc="0" normalizeH="0" baseline="0" noProof="0" dirty="0">
               <a:ln>
                 <a:noFill/>
               </a:ln>
@@ -6324,7 +6258,7 @@
               <a:tabLst/>
               <a:defRPr/>
             </a:pPr>
-            <a:endParaRPr kumimoji="0" lang="en-GB" sz="1600" b="1" i="0" u="none" strike="noStrike" kern="1200" cap="none" spc="0" normalizeH="0" baseline="0" noProof="0">
+            <a:endParaRPr kumimoji="0" lang="en-GB" sz="1600" b="1" i="0" u="none" strike="noStrike" kern="1200" cap="none" spc="0" normalizeH="0" baseline="0" noProof="0" dirty="0">
               <a:ln>
                 <a:noFill/>
               </a:ln>
@@ -6357,8 +6291,8 @@
         </p:nvSpPr>
         <p:spPr>
           <a:xfrm>
-            <a:off x="889000" y="3341760"/>
-            <a:ext cx="4899053" cy="2352102"/>
+            <a:off x="756000" y="3276000"/>
+            <a:ext cx="5184000" cy="2484000"/>
           </a:xfrm>
           <a:prstGeom prst="rect">
             <a:avLst/>
@@ -6703,70 +6637,12 @@
               </a:rPr>
               <a:t>Data Management Plan Bootcamp (In-Person)</a:t>
             </a:r>
-          </a:p>
-          <a:p>
-            <a:pPr marL="0" marR="0" lvl="0" indent="0" algn="l" defTabSz="1523848" rtl="0" eaLnBrk="1" fontAlgn="auto" latinLnBrk="0" hangingPunct="1">
-              <a:lnSpc>
-                <a:spcPct val="100000"/>
-              </a:lnSpc>
-              <a:spcBef>
-                <a:spcPts val="600"/>
-              </a:spcBef>
-              <a:spcAft>
-                <a:spcPts val="0"/>
-              </a:spcAft>
-              <a:buClrTx/>
-              <a:buSzTx/>
-              <a:buFont typeface="Arial" panose="020B0604020202020204" pitchFamily="34" charset="0"/>
-              <a:buNone/>
-              <a:tabLst/>
-              <a:defRPr/>
-            </a:pPr>
-            <a:endParaRPr kumimoji="0" lang="en-US" sz="1800" b="0" i="0" u="none" strike="noStrike" kern="1200" cap="none" spc="0" normalizeH="0" baseline="0" noProof="0" dirty="0">
+            <a:endParaRPr kumimoji="0" lang="en-GB" sz="1600" b="1" i="0" u="none" strike="noStrike" kern="1200" cap="none" spc="0" normalizeH="0" baseline="0" noProof="0" dirty="0">
               <a:ln>
                 <a:noFill/>
               </a:ln>
               <a:solidFill>
-                <a:srgbClr val="0F0F0F">
-                  <a:lumMod val="90000"/>
-                  <a:lumOff val="10000"/>
-                </a:srgbClr>
-              </a:solidFill>
-              <a:effectLst/>
-              <a:uLnTx/>
-              <a:uFillTx/>
-              <a:latin typeface="Aptos" panose="020B0004020202020204" pitchFamily="34" charset="0"/>
-              <a:ea typeface="+mn-ea"/>
-              <a:cs typeface="+mn-cs"/>
-            </a:endParaRPr>
-          </a:p>
-          <a:p>
-            <a:pPr marL="0" marR="0" lvl="0" indent="0" algn="l" defTabSz="1523848" rtl="0" eaLnBrk="1" fontAlgn="auto" latinLnBrk="0" hangingPunct="1">
-              <a:lnSpc>
-                <a:spcPct val="100000"/>
-              </a:lnSpc>
-              <a:spcBef>
-                <a:spcPts val="600"/>
-              </a:spcBef>
-              <a:spcAft>
-                <a:spcPts val="0"/>
-              </a:spcAft>
-              <a:buClrTx/>
-              <a:buSzTx/>
-              <a:buFont typeface="Arial" panose="020B0604020202020204" pitchFamily="34" charset="0"/>
-              <a:buNone/>
-              <a:tabLst/>
-              <a:defRPr/>
-            </a:pPr>
-            <a:endParaRPr kumimoji="0" lang="en-GB" sz="1500" b="1" i="0" u="none" strike="noStrike" kern="1200" cap="none" spc="0" normalizeH="0" baseline="0" noProof="0" dirty="0">
-              <a:ln>
-                <a:noFill/>
-              </a:ln>
-              <a:solidFill>
-                <a:srgbClr val="0F0F0F">
-                  <a:lumMod val="90000"/>
-                  <a:lumOff val="10000"/>
-                </a:srgbClr>
+                <a:srgbClr val="FFFFFF"/>
               </a:solidFill>
               <a:effectLst/>
               <a:uLnTx/>
@@ -6809,39 +6685,6 @@
               <a:cs typeface="+mn-cs"/>
             </a:endParaRPr>
           </a:p>
-          <a:p>
-            <a:pPr marL="0" marR="0" lvl="0" indent="0" algn="l" defTabSz="1523848" rtl="0" eaLnBrk="1" fontAlgn="auto" latinLnBrk="0" hangingPunct="1">
-              <a:lnSpc>
-                <a:spcPct val="90000"/>
-              </a:lnSpc>
-              <a:spcBef>
-                <a:spcPts val="1667"/>
-              </a:spcBef>
-              <a:spcAft>
-                <a:spcPts val="0"/>
-              </a:spcAft>
-              <a:buClrTx/>
-              <a:buSzTx/>
-              <a:buFont typeface="Arial" panose="020B0604020202020204" pitchFamily="34" charset="0"/>
-              <a:buNone/>
-              <a:tabLst/>
-              <a:defRPr/>
-            </a:pPr>
-            <a:endParaRPr kumimoji="0" lang="en-GB" sz="1600" b="1" i="0" u="none" strike="noStrike" kern="1200" cap="none" spc="0" normalizeH="0" baseline="0" noProof="0" dirty="0">
-              <a:ln>
-                <a:noFill/>
-              </a:ln>
-              <a:solidFill>
-                <a:srgbClr val="FFFFFF"/>
-              </a:solidFill>
-              <a:effectLst/>
-              <a:uLnTx/>
-              <a:uFillTx/>
-              <a:latin typeface="Aptos" panose="020B0004020202020204" pitchFamily="34" charset="0"/>
-              <a:ea typeface="+mn-ea"/>
-              <a:cs typeface="+mn-cs"/>
-            </a:endParaRPr>
-          </a:p>
         </p:txBody>
       </p:sp>
       <p:sp>
@@ -6860,8 +6703,8 @@
         </p:nvSpPr>
         <p:spPr>
           <a:xfrm>
-            <a:off x="6263193" y="1174560"/>
-            <a:ext cx="4920644" cy="1621429"/>
+            <a:off x="6156000" y="1116000"/>
+            <a:ext cx="5184000" cy="1944000"/>
           </a:xfrm>
           <a:prstGeom prst="rect">
             <a:avLst/>
@@ -7114,39 +6957,6 @@
               </a:rPr>
               <a:t>Scholarly Podcasting: Voices, Stories, &amp; Strategies</a:t>
             </a:r>
-          </a:p>
-          <a:p>
-            <a:pPr marL="0" marR="0" lvl="0" indent="0" algn="l" defTabSz="1523848" rtl="0" eaLnBrk="1" fontAlgn="auto" latinLnBrk="0" hangingPunct="1">
-              <a:lnSpc>
-                <a:spcPct val="100000"/>
-              </a:lnSpc>
-              <a:spcBef>
-                <a:spcPts val="0"/>
-              </a:spcBef>
-              <a:spcAft>
-                <a:spcPts val="0"/>
-              </a:spcAft>
-              <a:buClrTx/>
-              <a:buSzTx/>
-              <a:buFont typeface="Arial" panose="020B0604020202020204" pitchFamily="34" charset="0"/>
-              <a:buNone/>
-              <a:tabLst/>
-              <a:defRPr/>
-            </a:pPr>
-            <a:endParaRPr kumimoji="0" lang="en-US" sz="1500" b="0" i="0" u="none" strike="noStrike" kern="1200" cap="none" spc="0" normalizeH="0" baseline="0" noProof="0" dirty="0">
-              <a:ln>
-                <a:noFill/>
-              </a:ln>
-              <a:solidFill>
-                <a:srgbClr val="FFFFFF"/>
-              </a:solidFill>
-              <a:effectLst/>
-              <a:uLnTx/>
-              <a:uFillTx/>
-              <a:latin typeface="Aptos" panose="020B0004020202020204" pitchFamily="34" charset="0"/>
-              <a:ea typeface="+mn-ea"/>
-              <a:cs typeface="+mn-cs"/>
-            </a:endParaRPr>
           </a:p>
         </p:txBody>
       </p:sp>
@@ -7172,8 +6982,8 @@
         </p:blipFill>
         <p:spPr>
           <a:xfrm>
-            <a:off x="9721516" y="4373957"/>
-            <a:ext cx="2470484" cy="2470484"/>
+            <a:off x="9744000" y="4410000"/>
+            <a:ext cx="2448000" cy="2448000"/>
           </a:xfrm>
           <a:prstGeom prst="rect">
             <a:avLst/>
@@ -7238,8 +7048,8 @@
         </p:nvSpPr>
         <p:spPr>
           <a:xfrm>
-            <a:off x="6322519" y="4291127"/>
-            <a:ext cx="3146538" cy="1107996"/>
+            <a:off x="6156000" y="4140000"/>
+            <a:ext cx="3456000" cy="1620000"/>
           </a:xfrm>
           <a:prstGeom prst="rect">
             <a:avLst/>
@@ -7929,6 +7739,15 @@
 </file>
 
 <file path=customXml/item1.xml><?xml version="1.0" encoding="utf-8"?>
+<?mso-contentType ?>
+<FormTemplates xmlns="http://schemas.microsoft.com/sharepoint/v3/contenttype/forms">
+  <Display>DocumentLibraryForm</Display>
+  <Edit>DocumentLibraryForm</Edit>
+  <New>DocumentLibraryForm</New>
+</FormTemplates>
+</file>
+
+<file path=customXml/item2.xml><?xml version="1.0" encoding="utf-8"?>
 <p:properties xmlns:p="http://schemas.microsoft.com/office/2006/metadata/properties" xmlns:xsi="http://www.w3.org/2001/XMLSchema-instance" xmlns:pc="http://schemas.microsoft.com/office/infopath/2007/PartnerControls">
   <documentManagement>
     <TaxCatchAll xmlns="4842da2a-29f9-46a8-95a1-1e7813d5f154" xsi:nil="true"/>
@@ -7937,15 +7756,6 @@
     </lcf76f155ced4ddcb4097134ff3c332f>
   </documentManagement>
 </p:properties>
-</file>
-
-<file path=customXml/item2.xml><?xml version="1.0" encoding="utf-8"?>
-<?mso-contentType ?>
-<FormTemplates xmlns="http://schemas.microsoft.com/sharepoint/v3/contenttype/forms">
-  <Display>DocumentLibraryForm</Display>
-  <Edit>DocumentLibraryForm</Edit>
-  <New>DocumentLibraryForm</New>
-</FormTemplates>
 </file>
 
 <file path=customXml/item3.xml><?xml version="1.0" encoding="utf-8"?>
@@ -8210,20 +8020,20 @@
 </file>
 
 <file path=customXml/itemProps1.xml><?xml version="1.0" encoding="utf-8"?>
+<ds:datastoreItem xmlns:ds="http://schemas.openxmlformats.org/officeDocument/2006/customXml" ds:itemID="{6C58A332-C0D4-443B-915A-DCC3855EC41E}">
+  <ds:schemaRefs>
+    <ds:schemaRef ds:uri="http://schemas.microsoft.com/sharepoint/v3/contenttype/forms"/>
+  </ds:schemaRefs>
+</ds:datastoreItem>
+</file>
+
+<file path=customXml/itemProps2.xml><?xml version="1.0" encoding="utf-8"?>
 <ds:datastoreItem xmlns:ds="http://schemas.openxmlformats.org/officeDocument/2006/customXml" ds:itemID="{B4EDDCBC-432D-4F53-A678-E7EFA4AE544A}">
   <ds:schemaRefs>
     <ds:schemaRef ds:uri="http://schemas.microsoft.com/office/2006/metadata/properties"/>
     <ds:schemaRef ds:uri="http://schemas.microsoft.com/office/infopath/2007/PartnerControls"/>
     <ds:schemaRef ds:uri="4842da2a-29f9-46a8-95a1-1e7813d5f154"/>
     <ds:schemaRef ds:uri="4a227d49-acc8-45f3-a49c-e562db478c04"/>
-  </ds:schemaRefs>
-</ds:datastoreItem>
-</file>
-
-<file path=customXml/itemProps2.xml><?xml version="1.0" encoding="utf-8"?>
-<ds:datastoreItem xmlns:ds="http://schemas.openxmlformats.org/officeDocument/2006/customXml" ds:itemID="{6C58A332-C0D4-443B-915A-DCC3855EC41E}">
-  <ds:schemaRefs>
-    <ds:schemaRef ds:uri="http://schemas.microsoft.com/sharepoint/v3/contenttype/forms"/>
   </ds:schemaRefs>
 </ds:datastoreItem>
 </file>

</xml_diff>